<commit_message>
show template previews in readme
</commit_message>
<xml_diff>
--- a/templates/template_report.pptx
+++ b/templates/template_report.pptx
@@ -8,6 +8,8 @@
     <p:sldId id="256" r:id="rId7"/>
     <p:sldId id="257" r:id="rId8"/>
     <p:sldId id="258" r:id="rId9"/>
+    <p:sldId id="259" r:id="rId10"/>
+    <p:sldId id="260" r:id="rId11"/>
   </p:sldIdLst>
   <p:sldSz cx="12191695" cy="6858000" type="screen4x3"/>
   <p:notesSz cx="6858000" cy="9144000"/>
@@ -3244,7 +3246,7 @@
               </a:defRPr>
             </a:pPr>
             <a:r>
-              <a:t>2026-06-18 15:54</a:t>
+              <a:t>2026-06-18 16:05</a:t>
             </a:r>
           </a:p>
         </p:txBody>
@@ -4198,6 +4200,1278 @@
 </file>
 
 <file path=ppt/slides/slide3.xml><?xml version="1.0" encoding="utf-8"?>
+<p:sld xmlns:a="http://schemas.openxmlformats.org/drawingml/2006/main" xmlns:p="http://schemas.openxmlformats.org/presentationml/2006/main" xmlns:r="http://schemas.openxmlformats.org/officeDocument/2006/relationships">
+  <p:cSld>
+    <p:spTree>
+      <p:nvGrpSpPr>
+        <p:cNvPr id="1" name=""/>
+        <p:cNvGrpSpPr/>
+        <p:nvPr/>
+      </p:nvGrpSpPr>
+      <p:grpSpPr/>
+      <p:sp>
+        <p:nvSpPr>
+          <p:cNvPr id="2" name="TextBox 1"/>
+          <p:cNvSpPr txBox="1"/>
+          <p:nvPr/>
+        </p:nvSpPr>
+        <p:spPr>
+          <a:xfrm>
+            <a:off x="502920" y="292608"/>
+            <a:ext cx="10789920" cy="411480"/>
+          </a:xfrm>
+          <a:prstGeom prst="rect">
+            <a:avLst/>
+          </a:prstGeom>
+          <a:noFill/>
+        </p:spPr>
+        <p:txBody>
+          <a:bodyPr wrap="square">
+            <a:spAutoFit/>
+          </a:bodyPr>
+          <a:lstStyle/>
+          <a:p>
+            <a:pPr>
+              <a:defRPr sz="2400" b="1">
+                <a:solidFill>
+                  <a:srgbClr val="0B1F33"/>
+                </a:solidFill>
+                <a:latin typeface="Arial"/>
+              </a:defRPr>
+            </a:pPr>
+            <a:r>
+              <a:t>Score Board - Index 1</a:t>
+            </a:r>
+          </a:p>
+        </p:txBody>
+      </p:sp>
+      <p:sp>
+        <p:nvSpPr>
+          <p:cNvPr id="3" name="Rectangle 2"/>
+          <p:cNvSpPr/>
+          <p:nvPr/>
+        </p:nvSpPr>
+        <p:spPr>
+          <a:xfrm>
+            <a:off x="502920" y="786384"/>
+            <a:ext cx="1143000" cy="45720"/>
+          </a:xfrm>
+          <a:prstGeom prst="rect">
+            <a:avLst/>
+          </a:prstGeom>
+          <a:solidFill>
+            <a:srgbClr val="00A3A3"/>
+          </a:solidFill>
+          <a:ln>
+            <a:noFill/>
+          </a:ln>
+        </p:spPr>
+        <p:style>
+          <a:lnRef idx="1">
+            <a:schemeClr val="accent1"/>
+          </a:lnRef>
+          <a:fillRef idx="3">
+            <a:schemeClr val="accent1"/>
+          </a:fillRef>
+          <a:effectRef idx="2">
+            <a:schemeClr val="accent1"/>
+          </a:effectRef>
+          <a:fontRef idx="minor">
+            <a:schemeClr val="lt1"/>
+          </a:fontRef>
+        </p:style>
+        <p:txBody>
+          <a:bodyPr rtlCol="0" anchor="ctr"/>
+          <a:lstStyle/>
+          <a:p>
+            <a:pPr algn="ctr"/>
+          </a:p>
+        </p:txBody>
+      </p:sp>
+      <p:sp>
+        <p:nvSpPr>
+          <p:cNvPr id="4" name="TextBox 3"/>
+          <p:cNvSpPr txBox="1"/>
+          <p:nvPr/>
+        </p:nvSpPr>
+        <p:spPr>
+          <a:xfrm>
+            <a:off x="1783080" y="704088"/>
+            <a:ext cx="9509760" cy="228600"/>
+          </a:xfrm>
+          <a:prstGeom prst="rect">
+            <a:avLst/>
+          </a:prstGeom>
+          <a:noFill/>
+        </p:spPr>
+        <p:txBody>
+          <a:bodyPr wrap="square">
+            <a:spAutoFit/>
+          </a:bodyPr>
+          <a:lstStyle/>
+          <a:p>
+            <a:pPr>
+              <a:defRPr sz="1000" b="0">
+                <a:solidFill>
+                  <a:srgbClr val="6B7280"/>
+                </a:solidFill>
+                <a:latin typeface="Arial"/>
+              </a:defRPr>
+            </a:pPr>
+            <a:r>
+              <a:t>Wafer-level pass score by ADDP/reformatted index</a:t>
+            </a:r>
+          </a:p>
+        </p:txBody>
+      </p:sp>
+      <p:graphicFrame>
+        <p:nvGraphicFramePr>
+          <p:cNvPr id="5" name="Table 4"/>
+          <p:cNvGraphicFramePr>
+            <a:graphicFrameLocks noGrp="1"/>
+          </p:cNvGraphicFramePr>
+          <p:nvPr/>
+        </p:nvGraphicFramePr>
+        <p:xfrm>
+          <a:off x="502920" y="1143000"/>
+          <a:ext cx="11201400" cy="4480560"/>
+        </p:xfrm>
+        <a:graphic>
+          <a:graphicData uri="http://schemas.openxmlformats.org/drawingml/2006/table">
+            <a:tbl>
+              <a:tblPr firstRow="1" bandRow="1">
+                <a:tableStyleId>{5C22544A-7EE6-4342-B048-85BDC9FD1C3A}</a:tableStyleId>
+              </a:tblPr>
+              <a:tblGrid>
+                <a:gridCol w="2800350"/>
+                <a:gridCol w="2800350"/>
+                <a:gridCol w="2800350"/>
+                <a:gridCol w="2800350"/>
+              </a:tblGrid>
+              <a:tr h="2240280">
+                <a:tc>
+                  <a:txBody>
+                    <a:bodyPr/>
+                    <a:lstStyle/>
+                    <a:p>
+                      <a:pPr algn="ctr">
+                        <a:defRPr sz="800" b="1">
+                          <a:solidFill>
+                            <a:srgbClr val="FFFFFF"/>
+                          </a:solidFill>
+                          <a:latin typeface="Arial"/>
+                        </a:defRPr>
+                      </a:pPr>
+                      <a:r>
+                        <a:t>Index</a:t>
+                      </a:r>
+                    </a:p>
+                  </a:txBody>
+                  <a:tcPr>
+                    <a:solidFill>
+                      <a:srgbClr val="0B1F33"/>
+                    </a:solidFill>
+                  </a:tcPr>
+                </a:tc>
+                <a:tc>
+                  <a:txBody>
+                    <a:bodyPr/>
+                    <a:lstStyle/>
+                    <a:p>
+                      <a:pPr algn="ctr">
+                        <a:defRPr sz="800" b="1">
+                          <a:solidFill>
+                            <a:srgbClr val="FFFFFF"/>
+                          </a:solidFill>
+                          <a:latin typeface="Arial"/>
+                        </a:defRPr>
+                      </a:pPr>
+                      <a:r>
+                        <a:t>W01</a:t>
+                      </a:r>
+                    </a:p>
+                  </a:txBody>
+                  <a:tcPr>
+                    <a:solidFill>
+                      <a:srgbClr val="0B1F33"/>
+                    </a:solidFill>
+                  </a:tcPr>
+                </a:tc>
+                <a:tc>
+                  <a:txBody>
+                    <a:bodyPr/>
+                    <a:lstStyle/>
+                    <a:p>
+                      <a:pPr algn="ctr">
+                        <a:defRPr sz="800" b="1">
+                          <a:solidFill>
+                            <a:srgbClr val="FFFFFF"/>
+                          </a:solidFill>
+                          <a:latin typeface="Arial"/>
+                        </a:defRPr>
+                      </a:pPr>
+                      <a:r>
+                        <a:t>W02</a:t>
+                      </a:r>
+                    </a:p>
+                  </a:txBody>
+                  <a:tcPr>
+                    <a:solidFill>
+                      <a:srgbClr val="0B1F33"/>
+                    </a:solidFill>
+                  </a:tcPr>
+                </a:tc>
+                <a:tc>
+                  <a:txBody>
+                    <a:bodyPr/>
+                    <a:lstStyle/>
+                    <a:p>
+                      <a:pPr algn="ctr">
+                        <a:defRPr sz="800" b="1">
+                          <a:solidFill>
+                            <a:srgbClr val="FFFFFF"/>
+                          </a:solidFill>
+                          <a:latin typeface="Arial"/>
+                        </a:defRPr>
+                      </a:pPr>
+                      <a:r>
+                        <a:t>W03</a:t>
+                      </a:r>
+                    </a:p>
+                  </a:txBody>
+                  <a:tcPr>
+                    <a:solidFill>
+                      <a:srgbClr val="0B1F33"/>
+                    </a:solidFill>
+                  </a:tcPr>
+                </a:tc>
+              </a:tr>
+              <a:tr h="2240280">
+                <a:tc>
+                  <a:txBody>
+                    <a:bodyPr/>
+                    <a:lstStyle/>
+                    <a:p>
+                      <a:pPr algn="ctr">
+                        <a:defRPr sz="800">
+                          <a:solidFill>
+                            <a:srgbClr val="1F2937"/>
+                          </a:solidFill>
+                          <a:latin typeface="Arial"/>
+                        </a:defRPr>
+                      </a:pPr>
+                      <a:r>
+                        <a:t>ADDP_ITEM_01</a:t>
+                      </a:r>
+                    </a:p>
+                  </a:txBody>
+                  <a:tcPr>
+                    <a:solidFill>
+                      <a:srgbClr val="F8FAFC"/>
+                    </a:solidFill>
+                  </a:tcPr>
+                </a:tc>
+                <a:tc>
+                  <a:txBody>
+                    <a:bodyPr/>
+                    <a:lstStyle/>
+                    <a:p>
+                      <a:pPr algn="ctr">
+                        <a:defRPr sz="800">
+                          <a:solidFill>
+                            <a:srgbClr val="1F2937"/>
+                          </a:solidFill>
+                          <a:latin typeface="Arial"/>
+                        </a:defRPr>
+                      </a:pPr>
+                      <a:r>
+                        <a:t>100</a:t>
+                      </a:r>
+                    </a:p>
+                  </a:txBody>
+                  <a:tcPr>
+                    <a:solidFill>
+                      <a:srgbClr val="DCFCE7"/>
+                    </a:solidFill>
+                  </a:tcPr>
+                </a:tc>
+                <a:tc>
+                  <a:txBody>
+                    <a:bodyPr/>
+                    <a:lstStyle/>
+                    <a:p>
+                      <a:pPr algn="ctr">
+                        <a:defRPr sz="800">
+                          <a:solidFill>
+                            <a:srgbClr val="1F2937"/>
+                          </a:solidFill>
+                          <a:latin typeface="Arial"/>
+                        </a:defRPr>
+                      </a:pPr>
+                      <a:r>
+                        <a:t>100</a:t>
+                      </a:r>
+                    </a:p>
+                  </a:txBody>
+                  <a:tcPr>
+                    <a:solidFill>
+                      <a:srgbClr val="DCFCE7"/>
+                    </a:solidFill>
+                  </a:tcPr>
+                </a:tc>
+                <a:tc>
+                  <a:txBody>
+                    <a:bodyPr/>
+                    <a:lstStyle/>
+                    <a:p>
+                      <a:pPr algn="ctr">
+                        <a:defRPr sz="800">
+                          <a:solidFill>
+                            <a:srgbClr val="1F2937"/>
+                          </a:solidFill>
+                          <a:latin typeface="Arial"/>
+                        </a:defRPr>
+                      </a:pPr>
+                      <a:r>
+                        <a:t>100</a:t>
+                      </a:r>
+                    </a:p>
+                  </a:txBody>
+                  <a:tcPr>
+                    <a:solidFill>
+                      <a:srgbClr val="DCFCE7"/>
+                    </a:solidFill>
+                  </a:tcPr>
+                </a:tc>
+              </a:tr>
+            </a:tbl>
+          </a:graphicData>
+        </a:graphic>
+      </p:graphicFrame>
+      <p:sp>
+        <p:nvSpPr>
+          <p:cNvPr id="6" name="Rectangle 5"/>
+          <p:cNvSpPr/>
+          <p:nvPr/>
+        </p:nvSpPr>
+        <p:spPr>
+          <a:xfrm>
+            <a:off x="594360" y="5806440"/>
+            <a:ext cx="228600" cy="164592"/>
+          </a:xfrm>
+          <a:prstGeom prst="rect">
+            <a:avLst/>
+          </a:prstGeom>
+          <a:solidFill>
+            <a:srgbClr val="DCFCE7"/>
+          </a:solidFill>
+          <a:ln>
+            <a:solidFill>
+              <a:srgbClr val="CBD5E1"/>
+            </a:solidFill>
+          </a:ln>
+        </p:spPr>
+        <p:style>
+          <a:lnRef idx="1">
+            <a:schemeClr val="accent1"/>
+          </a:lnRef>
+          <a:fillRef idx="3">
+            <a:schemeClr val="accent1"/>
+          </a:fillRef>
+          <a:effectRef idx="2">
+            <a:schemeClr val="accent1"/>
+          </a:effectRef>
+          <a:fontRef idx="minor">
+            <a:schemeClr val="lt1"/>
+          </a:fontRef>
+        </p:style>
+        <p:txBody>
+          <a:bodyPr rtlCol="0" anchor="ctr"/>
+          <a:lstStyle/>
+          <a:p>
+            <a:pPr algn="ctr"/>
+          </a:p>
+        </p:txBody>
+      </p:sp>
+      <p:sp>
+        <p:nvSpPr>
+          <p:cNvPr id="7" name="TextBox 6"/>
+          <p:cNvSpPr txBox="1"/>
+          <p:nvPr/>
+        </p:nvSpPr>
+        <p:spPr>
+          <a:xfrm>
+            <a:off x="886968" y="5742432"/>
+            <a:ext cx="777240" cy="228600"/>
+          </a:xfrm>
+          <a:prstGeom prst="rect">
+            <a:avLst/>
+          </a:prstGeom>
+          <a:noFill/>
+        </p:spPr>
+        <p:txBody>
+          <a:bodyPr wrap="square">
+            <a:spAutoFit/>
+          </a:bodyPr>
+          <a:lstStyle/>
+          <a:p>
+            <a:pPr>
+              <a:defRPr sz="800" b="0">
+                <a:solidFill>
+                  <a:srgbClr val="6B7280"/>
+                </a:solidFill>
+                <a:latin typeface="Arial"/>
+              </a:defRPr>
+            </a:pPr>
+            <a:r>
+              <a:t>&gt;=95</a:t>
+            </a:r>
+          </a:p>
+        </p:txBody>
+      </p:sp>
+      <p:sp>
+        <p:nvSpPr>
+          <p:cNvPr id="8" name="Rectangle 7"/>
+          <p:cNvSpPr/>
+          <p:nvPr/>
+        </p:nvSpPr>
+        <p:spPr>
+          <a:xfrm>
+            <a:off x="1737360" y="5806440"/>
+            <a:ext cx="228600" cy="164592"/>
+          </a:xfrm>
+          <a:prstGeom prst="rect">
+            <a:avLst/>
+          </a:prstGeom>
+          <a:solidFill>
+            <a:srgbClr val="FEF9C3"/>
+          </a:solidFill>
+          <a:ln>
+            <a:solidFill>
+              <a:srgbClr val="CBD5E1"/>
+            </a:solidFill>
+          </a:ln>
+        </p:spPr>
+        <p:style>
+          <a:lnRef idx="1">
+            <a:schemeClr val="accent1"/>
+          </a:lnRef>
+          <a:fillRef idx="3">
+            <a:schemeClr val="accent1"/>
+          </a:fillRef>
+          <a:effectRef idx="2">
+            <a:schemeClr val="accent1"/>
+          </a:effectRef>
+          <a:fontRef idx="minor">
+            <a:schemeClr val="lt1"/>
+          </a:fontRef>
+        </p:style>
+        <p:txBody>
+          <a:bodyPr rtlCol="0" anchor="ctr"/>
+          <a:lstStyle/>
+          <a:p>
+            <a:pPr algn="ctr"/>
+          </a:p>
+        </p:txBody>
+      </p:sp>
+      <p:sp>
+        <p:nvSpPr>
+          <p:cNvPr id="9" name="TextBox 8"/>
+          <p:cNvSpPr txBox="1"/>
+          <p:nvPr/>
+        </p:nvSpPr>
+        <p:spPr>
+          <a:xfrm>
+            <a:off x="2029968" y="5742432"/>
+            <a:ext cx="777240" cy="228600"/>
+          </a:xfrm>
+          <a:prstGeom prst="rect">
+            <a:avLst/>
+          </a:prstGeom>
+          <a:noFill/>
+        </p:spPr>
+        <p:txBody>
+          <a:bodyPr wrap="square">
+            <a:spAutoFit/>
+          </a:bodyPr>
+          <a:lstStyle/>
+          <a:p>
+            <a:pPr>
+              <a:defRPr sz="800" b="0">
+                <a:solidFill>
+                  <a:srgbClr val="6B7280"/>
+                </a:solidFill>
+                <a:latin typeface="Arial"/>
+              </a:defRPr>
+            </a:pPr>
+            <a:r>
+              <a:t>80-94.9</a:t>
+            </a:r>
+          </a:p>
+        </p:txBody>
+      </p:sp>
+      <p:sp>
+        <p:nvSpPr>
+          <p:cNvPr id="10" name="Rectangle 9"/>
+          <p:cNvSpPr/>
+          <p:nvPr/>
+        </p:nvSpPr>
+        <p:spPr>
+          <a:xfrm>
+            <a:off x="2880360" y="5806440"/>
+            <a:ext cx="228600" cy="164592"/>
+          </a:xfrm>
+          <a:prstGeom prst="rect">
+            <a:avLst/>
+          </a:prstGeom>
+          <a:solidFill>
+            <a:srgbClr val="FEE2E2"/>
+          </a:solidFill>
+          <a:ln>
+            <a:solidFill>
+              <a:srgbClr val="CBD5E1"/>
+            </a:solidFill>
+          </a:ln>
+        </p:spPr>
+        <p:style>
+          <a:lnRef idx="1">
+            <a:schemeClr val="accent1"/>
+          </a:lnRef>
+          <a:fillRef idx="3">
+            <a:schemeClr val="accent1"/>
+          </a:fillRef>
+          <a:effectRef idx="2">
+            <a:schemeClr val="accent1"/>
+          </a:effectRef>
+          <a:fontRef idx="minor">
+            <a:schemeClr val="lt1"/>
+          </a:fontRef>
+        </p:style>
+        <p:txBody>
+          <a:bodyPr rtlCol="0" anchor="ctr"/>
+          <a:lstStyle/>
+          <a:p>
+            <a:pPr algn="ctr"/>
+          </a:p>
+        </p:txBody>
+      </p:sp>
+      <p:sp>
+        <p:nvSpPr>
+          <p:cNvPr id="11" name="TextBox 10"/>
+          <p:cNvSpPr txBox="1"/>
+          <p:nvPr/>
+        </p:nvSpPr>
+        <p:spPr>
+          <a:xfrm>
+            <a:off x="3172968" y="5742432"/>
+            <a:ext cx="777240" cy="228600"/>
+          </a:xfrm>
+          <a:prstGeom prst="rect">
+            <a:avLst/>
+          </a:prstGeom>
+          <a:noFill/>
+        </p:spPr>
+        <p:txBody>
+          <a:bodyPr wrap="square">
+            <a:spAutoFit/>
+          </a:bodyPr>
+          <a:lstStyle/>
+          <a:p>
+            <a:pPr>
+              <a:defRPr sz="800" b="0">
+                <a:solidFill>
+                  <a:srgbClr val="6B7280"/>
+                </a:solidFill>
+                <a:latin typeface="Arial"/>
+              </a:defRPr>
+            </a:pPr>
+            <a:r>
+              <a:t>&lt;80</a:t>
+            </a:r>
+          </a:p>
+        </p:txBody>
+      </p:sp>
+      <p:sp>
+        <p:nvSpPr>
+          <p:cNvPr id="12" name="TextBox 11"/>
+          <p:cNvSpPr txBox="1"/>
+          <p:nvPr/>
+        </p:nvSpPr>
+        <p:spPr>
+          <a:xfrm>
+            <a:off x="411480" y="6446520"/>
+            <a:ext cx="11338560" cy="228600"/>
+          </a:xfrm>
+          <a:prstGeom prst="rect">
+            <a:avLst/>
+          </a:prstGeom>
+          <a:noFill/>
+        </p:spPr>
+        <p:txBody>
+          <a:bodyPr wrap="square">
+            <a:spAutoFit/>
+          </a:bodyPr>
+          <a:lstStyle/>
+          <a:p>
+            <a:pPr>
+              <a:defRPr sz="800" b="0">
+                <a:solidFill>
+                  <a:srgbClr val="6B7280"/>
+                </a:solidFill>
+                <a:latin typeface="Arial"/>
+              </a:defRPr>
+            </a:pPr>
+            <a:r>
+              <a:t>Index 1 example uses per-wafer pass rate against reformatter spec limits.</a:t>
+            </a:r>
+          </a:p>
+        </p:txBody>
+      </p:sp>
+    </p:spTree>
+  </p:cSld>
+  <p:clrMapOvr>
+    <a:masterClrMapping/>
+  </p:clrMapOvr>
+</p:sld>
+</file>
+
+<file path=ppt/slides/slide4.xml><?xml version="1.0" encoding="utf-8"?>
+<p:sld xmlns:a="http://schemas.openxmlformats.org/drawingml/2006/main" xmlns:p="http://schemas.openxmlformats.org/presentationml/2006/main" xmlns:r="http://schemas.openxmlformats.org/officeDocument/2006/relationships">
+  <p:cSld>
+    <p:spTree>
+      <p:nvGrpSpPr>
+        <p:cNvPr id="1" name=""/>
+        <p:cNvGrpSpPr/>
+        <p:nvPr/>
+      </p:nvGrpSpPr>
+      <p:grpSpPr/>
+      <p:sp>
+        <p:nvSpPr>
+          <p:cNvPr id="2" name="TextBox 1"/>
+          <p:cNvSpPr txBox="1"/>
+          <p:nvPr/>
+        </p:nvSpPr>
+        <p:spPr>
+          <a:xfrm>
+            <a:off x="502920" y="292608"/>
+            <a:ext cx="10789920" cy="411480"/>
+          </a:xfrm>
+          <a:prstGeom prst="rect">
+            <a:avLst/>
+          </a:prstGeom>
+          <a:noFill/>
+        </p:spPr>
+        <p:txBody>
+          <a:bodyPr wrap="square">
+            <a:spAutoFit/>
+          </a:bodyPr>
+          <a:lstStyle/>
+          <a:p>
+            <a:pPr>
+              <a:defRPr sz="2400" b="1">
+                <a:solidFill>
+                  <a:srgbClr val="0B1F33"/>
+                </a:solidFill>
+                <a:latin typeface="Arial"/>
+              </a:defRPr>
+            </a:pPr>
+            <a:r>
+              <a:t>Score Board - Index 2</a:t>
+            </a:r>
+          </a:p>
+        </p:txBody>
+      </p:sp>
+      <p:sp>
+        <p:nvSpPr>
+          <p:cNvPr id="3" name="Rectangle 2"/>
+          <p:cNvSpPr/>
+          <p:nvPr/>
+        </p:nvSpPr>
+        <p:spPr>
+          <a:xfrm>
+            <a:off x="502920" y="786384"/>
+            <a:ext cx="1143000" cy="45720"/>
+          </a:xfrm>
+          <a:prstGeom prst="rect">
+            <a:avLst/>
+          </a:prstGeom>
+          <a:solidFill>
+            <a:srgbClr val="00A3A3"/>
+          </a:solidFill>
+          <a:ln>
+            <a:noFill/>
+          </a:ln>
+        </p:spPr>
+        <p:style>
+          <a:lnRef idx="1">
+            <a:schemeClr val="accent1"/>
+          </a:lnRef>
+          <a:fillRef idx="3">
+            <a:schemeClr val="accent1"/>
+          </a:fillRef>
+          <a:effectRef idx="2">
+            <a:schemeClr val="accent1"/>
+          </a:effectRef>
+          <a:fontRef idx="minor">
+            <a:schemeClr val="lt1"/>
+          </a:fontRef>
+        </p:style>
+        <p:txBody>
+          <a:bodyPr rtlCol="0" anchor="ctr"/>
+          <a:lstStyle/>
+          <a:p>
+            <a:pPr algn="ctr"/>
+          </a:p>
+        </p:txBody>
+      </p:sp>
+      <p:sp>
+        <p:nvSpPr>
+          <p:cNvPr id="4" name="TextBox 3"/>
+          <p:cNvSpPr txBox="1"/>
+          <p:nvPr/>
+        </p:nvSpPr>
+        <p:spPr>
+          <a:xfrm>
+            <a:off x="1783080" y="704088"/>
+            <a:ext cx="9509760" cy="228600"/>
+          </a:xfrm>
+          <a:prstGeom prst="rect">
+            <a:avLst/>
+          </a:prstGeom>
+          <a:noFill/>
+        </p:spPr>
+        <p:txBody>
+          <a:bodyPr wrap="square">
+            <a:spAutoFit/>
+          </a:bodyPr>
+          <a:lstStyle/>
+          <a:p>
+            <a:pPr>
+              <a:defRPr sz="1000" b="0">
+                <a:solidFill>
+                  <a:srgbClr val="6B7280"/>
+                </a:solidFill>
+                <a:latin typeface="Arial"/>
+              </a:defRPr>
+            </a:pPr>
+            <a:r>
+              <a:t>Wafer-level median value by ADDP/reformatted index</a:t>
+            </a:r>
+          </a:p>
+        </p:txBody>
+      </p:sp>
+      <p:graphicFrame>
+        <p:nvGraphicFramePr>
+          <p:cNvPr id="5" name="Table 4"/>
+          <p:cNvGraphicFramePr>
+            <a:graphicFrameLocks noGrp="1"/>
+          </p:cNvGraphicFramePr>
+          <p:nvPr/>
+        </p:nvGraphicFramePr>
+        <p:xfrm>
+          <a:off x="502920" y="1143000"/>
+          <a:ext cx="11201400" cy="4480560"/>
+        </p:xfrm>
+        <a:graphic>
+          <a:graphicData uri="http://schemas.openxmlformats.org/drawingml/2006/table">
+            <a:tbl>
+              <a:tblPr firstRow="1" bandRow="1">
+                <a:tableStyleId>{5C22544A-7EE6-4342-B048-85BDC9FD1C3A}</a:tableStyleId>
+              </a:tblPr>
+              <a:tblGrid>
+                <a:gridCol w="2800350"/>
+                <a:gridCol w="2800350"/>
+                <a:gridCol w="2800350"/>
+                <a:gridCol w="2800350"/>
+              </a:tblGrid>
+              <a:tr h="2240280">
+                <a:tc>
+                  <a:txBody>
+                    <a:bodyPr/>
+                    <a:lstStyle/>
+                    <a:p>
+                      <a:pPr algn="ctr">
+                        <a:defRPr sz="800" b="1">
+                          <a:solidFill>
+                            <a:srgbClr val="FFFFFF"/>
+                          </a:solidFill>
+                          <a:latin typeface="Arial"/>
+                        </a:defRPr>
+                      </a:pPr>
+                      <a:r>
+                        <a:t>Index</a:t>
+                      </a:r>
+                    </a:p>
+                  </a:txBody>
+                  <a:tcPr>
+                    <a:solidFill>
+                      <a:srgbClr val="0B1F33"/>
+                    </a:solidFill>
+                  </a:tcPr>
+                </a:tc>
+                <a:tc>
+                  <a:txBody>
+                    <a:bodyPr/>
+                    <a:lstStyle/>
+                    <a:p>
+                      <a:pPr algn="ctr">
+                        <a:defRPr sz="800" b="1">
+                          <a:solidFill>
+                            <a:srgbClr val="FFFFFF"/>
+                          </a:solidFill>
+                          <a:latin typeface="Arial"/>
+                        </a:defRPr>
+                      </a:pPr>
+                      <a:r>
+                        <a:t>W01</a:t>
+                      </a:r>
+                    </a:p>
+                  </a:txBody>
+                  <a:tcPr>
+                    <a:solidFill>
+                      <a:srgbClr val="0B1F33"/>
+                    </a:solidFill>
+                  </a:tcPr>
+                </a:tc>
+                <a:tc>
+                  <a:txBody>
+                    <a:bodyPr/>
+                    <a:lstStyle/>
+                    <a:p>
+                      <a:pPr algn="ctr">
+                        <a:defRPr sz="800" b="1">
+                          <a:solidFill>
+                            <a:srgbClr val="FFFFFF"/>
+                          </a:solidFill>
+                          <a:latin typeface="Arial"/>
+                        </a:defRPr>
+                      </a:pPr>
+                      <a:r>
+                        <a:t>W02</a:t>
+                      </a:r>
+                    </a:p>
+                  </a:txBody>
+                  <a:tcPr>
+                    <a:solidFill>
+                      <a:srgbClr val="0B1F33"/>
+                    </a:solidFill>
+                  </a:tcPr>
+                </a:tc>
+                <a:tc>
+                  <a:txBody>
+                    <a:bodyPr/>
+                    <a:lstStyle/>
+                    <a:p>
+                      <a:pPr algn="ctr">
+                        <a:defRPr sz="800" b="1">
+                          <a:solidFill>
+                            <a:srgbClr val="FFFFFF"/>
+                          </a:solidFill>
+                          <a:latin typeface="Arial"/>
+                        </a:defRPr>
+                      </a:pPr>
+                      <a:r>
+                        <a:t>W03</a:t>
+                      </a:r>
+                    </a:p>
+                  </a:txBody>
+                  <a:tcPr>
+                    <a:solidFill>
+                      <a:srgbClr val="0B1F33"/>
+                    </a:solidFill>
+                  </a:tcPr>
+                </a:tc>
+              </a:tr>
+              <a:tr h="2240280">
+                <a:tc>
+                  <a:txBody>
+                    <a:bodyPr/>
+                    <a:lstStyle/>
+                    <a:p>
+                      <a:pPr algn="ctr">
+                        <a:defRPr sz="800">
+                          <a:solidFill>
+                            <a:srgbClr val="1F2937"/>
+                          </a:solidFill>
+                          <a:latin typeface="Arial"/>
+                        </a:defRPr>
+                      </a:pPr>
+                      <a:r>
+                        <a:t>ADDP_ITEM_01</a:t>
+                      </a:r>
+                    </a:p>
+                  </a:txBody>
+                  <a:tcPr>
+                    <a:solidFill>
+                      <a:srgbClr val="F8FAFC"/>
+                    </a:solidFill>
+                  </a:tcPr>
+                </a:tc>
+                <a:tc>
+                  <a:txBody>
+                    <a:bodyPr/>
+                    <a:lstStyle/>
+                    <a:p>
+                      <a:pPr algn="ctr">
+                        <a:defRPr sz="800">
+                          <a:solidFill>
+                            <a:srgbClr val="1F2937"/>
+                          </a:solidFill>
+                          <a:latin typeface="Arial"/>
+                        </a:defRPr>
+                      </a:pPr>
+                      <a:r>
+                        <a:t>52</a:t>
+                      </a:r>
+                    </a:p>
+                  </a:txBody>
+                  <a:tcPr>
+                    <a:solidFill>
+                      <a:srgbClr val="FEE2E2"/>
+                    </a:solidFill>
+                  </a:tcPr>
+                </a:tc>
+                <a:tc>
+                  <a:txBody>
+                    <a:bodyPr/>
+                    <a:lstStyle/>
+                    <a:p>
+                      <a:pPr algn="ctr">
+                        <a:defRPr sz="800">
+                          <a:solidFill>
+                            <a:srgbClr val="1F2937"/>
+                          </a:solidFill>
+                          <a:latin typeface="Arial"/>
+                        </a:defRPr>
+                      </a:pPr>
+                      <a:r>
+                        <a:t>62</a:t>
+                      </a:r>
+                    </a:p>
+                  </a:txBody>
+                  <a:tcPr>
+                    <a:solidFill>
+                      <a:srgbClr val="FEE2E2"/>
+                    </a:solidFill>
+                  </a:tcPr>
+                </a:tc>
+                <a:tc>
+                  <a:txBody>
+                    <a:bodyPr/>
+                    <a:lstStyle/>
+                    <a:p>
+                      <a:pPr algn="ctr">
+                        <a:defRPr sz="800">
+                          <a:solidFill>
+                            <a:srgbClr val="1F2937"/>
+                          </a:solidFill>
+                          <a:latin typeface="Arial"/>
+                        </a:defRPr>
+                      </a:pPr>
+                      <a:r>
+                        <a:t>72</a:t>
+                      </a:r>
+                    </a:p>
+                  </a:txBody>
+                  <a:tcPr>
+                    <a:solidFill>
+                      <a:srgbClr val="FEE2E2"/>
+                    </a:solidFill>
+                  </a:tcPr>
+                </a:tc>
+              </a:tr>
+            </a:tbl>
+          </a:graphicData>
+        </a:graphic>
+      </p:graphicFrame>
+      <p:sp>
+        <p:nvSpPr>
+          <p:cNvPr id="6" name="Rectangle 5"/>
+          <p:cNvSpPr/>
+          <p:nvPr/>
+        </p:nvSpPr>
+        <p:spPr>
+          <a:xfrm>
+            <a:off x="594360" y="5806440"/>
+            <a:ext cx="228600" cy="164592"/>
+          </a:xfrm>
+          <a:prstGeom prst="rect">
+            <a:avLst/>
+          </a:prstGeom>
+          <a:solidFill>
+            <a:srgbClr val="DCFCE7"/>
+          </a:solidFill>
+          <a:ln>
+            <a:solidFill>
+              <a:srgbClr val="CBD5E1"/>
+            </a:solidFill>
+          </a:ln>
+        </p:spPr>
+        <p:style>
+          <a:lnRef idx="1">
+            <a:schemeClr val="accent1"/>
+          </a:lnRef>
+          <a:fillRef idx="3">
+            <a:schemeClr val="accent1"/>
+          </a:fillRef>
+          <a:effectRef idx="2">
+            <a:schemeClr val="accent1"/>
+          </a:effectRef>
+          <a:fontRef idx="minor">
+            <a:schemeClr val="lt1"/>
+          </a:fontRef>
+        </p:style>
+        <p:txBody>
+          <a:bodyPr rtlCol="0" anchor="ctr"/>
+          <a:lstStyle/>
+          <a:p>
+            <a:pPr algn="ctr"/>
+          </a:p>
+        </p:txBody>
+      </p:sp>
+      <p:sp>
+        <p:nvSpPr>
+          <p:cNvPr id="7" name="TextBox 6"/>
+          <p:cNvSpPr txBox="1"/>
+          <p:nvPr/>
+        </p:nvSpPr>
+        <p:spPr>
+          <a:xfrm>
+            <a:off x="886968" y="5742432"/>
+            <a:ext cx="777240" cy="228600"/>
+          </a:xfrm>
+          <a:prstGeom prst="rect">
+            <a:avLst/>
+          </a:prstGeom>
+          <a:noFill/>
+        </p:spPr>
+        <p:txBody>
+          <a:bodyPr wrap="square">
+            <a:spAutoFit/>
+          </a:bodyPr>
+          <a:lstStyle/>
+          <a:p>
+            <a:pPr>
+              <a:defRPr sz="800" b="0">
+                <a:solidFill>
+                  <a:srgbClr val="6B7280"/>
+                </a:solidFill>
+                <a:latin typeface="Arial"/>
+              </a:defRPr>
+            </a:pPr>
+            <a:r>
+              <a:t>&gt;=95</a:t>
+            </a:r>
+          </a:p>
+        </p:txBody>
+      </p:sp>
+      <p:sp>
+        <p:nvSpPr>
+          <p:cNvPr id="8" name="Rectangle 7"/>
+          <p:cNvSpPr/>
+          <p:nvPr/>
+        </p:nvSpPr>
+        <p:spPr>
+          <a:xfrm>
+            <a:off x="1737360" y="5806440"/>
+            <a:ext cx="228600" cy="164592"/>
+          </a:xfrm>
+          <a:prstGeom prst="rect">
+            <a:avLst/>
+          </a:prstGeom>
+          <a:solidFill>
+            <a:srgbClr val="FEF9C3"/>
+          </a:solidFill>
+          <a:ln>
+            <a:solidFill>
+              <a:srgbClr val="CBD5E1"/>
+            </a:solidFill>
+          </a:ln>
+        </p:spPr>
+        <p:style>
+          <a:lnRef idx="1">
+            <a:schemeClr val="accent1"/>
+          </a:lnRef>
+          <a:fillRef idx="3">
+            <a:schemeClr val="accent1"/>
+          </a:fillRef>
+          <a:effectRef idx="2">
+            <a:schemeClr val="accent1"/>
+          </a:effectRef>
+          <a:fontRef idx="minor">
+            <a:schemeClr val="lt1"/>
+          </a:fontRef>
+        </p:style>
+        <p:txBody>
+          <a:bodyPr rtlCol="0" anchor="ctr"/>
+          <a:lstStyle/>
+          <a:p>
+            <a:pPr algn="ctr"/>
+          </a:p>
+        </p:txBody>
+      </p:sp>
+      <p:sp>
+        <p:nvSpPr>
+          <p:cNvPr id="9" name="TextBox 8"/>
+          <p:cNvSpPr txBox="1"/>
+          <p:nvPr/>
+        </p:nvSpPr>
+        <p:spPr>
+          <a:xfrm>
+            <a:off x="2029968" y="5742432"/>
+            <a:ext cx="777240" cy="228600"/>
+          </a:xfrm>
+          <a:prstGeom prst="rect">
+            <a:avLst/>
+          </a:prstGeom>
+          <a:noFill/>
+        </p:spPr>
+        <p:txBody>
+          <a:bodyPr wrap="square">
+            <a:spAutoFit/>
+          </a:bodyPr>
+          <a:lstStyle/>
+          <a:p>
+            <a:pPr>
+              <a:defRPr sz="800" b="0">
+                <a:solidFill>
+                  <a:srgbClr val="6B7280"/>
+                </a:solidFill>
+                <a:latin typeface="Arial"/>
+              </a:defRPr>
+            </a:pPr>
+            <a:r>
+              <a:t>80-94.9</a:t>
+            </a:r>
+          </a:p>
+        </p:txBody>
+      </p:sp>
+      <p:sp>
+        <p:nvSpPr>
+          <p:cNvPr id="10" name="Rectangle 9"/>
+          <p:cNvSpPr/>
+          <p:nvPr/>
+        </p:nvSpPr>
+        <p:spPr>
+          <a:xfrm>
+            <a:off x="2880360" y="5806440"/>
+            <a:ext cx="228600" cy="164592"/>
+          </a:xfrm>
+          <a:prstGeom prst="rect">
+            <a:avLst/>
+          </a:prstGeom>
+          <a:solidFill>
+            <a:srgbClr val="FEE2E2"/>
+          </a:solidFill>
+          <a:ln>
+            <a:solidFill>
+              <a:srgbClr val="CBD5E1"/>
+            </a:solidFill>
+          </a:ln>
+        </p:spPr>
+        <p:style>
+          <a:lnRef idx="1">
+            <a:schemeClr val="accent1"/>
+          </a:lnRef>
+          <a:fillRef idx="3">
+            <a:schemeClr val="accent1"/>
+          </a:fillRef>
+          <a:effectRef idx="2">
+            <a:schemeClr val="accent1"/>
+          </a:effectRef>
+          <a:fontRef idx="minor">
+            <a:schemeClr val="lt1"/>
+          </a:fontRef>
+        </p:style>
+        <p:txBody>
+          <a:bodyPr rtlCol="0" anchor="ctr"/>
+          <a:lstStyle/>
+          <a:p>
+            <a:pPr algn="ctr"/>
+          </a:p>
+        </p:txBody>
+      </p:sp>
+      <p:sp>
+        <p:nvSpPr>
+          <p:cNvPr id="11" name="TextBox 10"/>
+          <p:cNvSpPr txBox="1"/>
+          <p:nvPr/>
+        </p:nvSpPr>
+        <p:spPr>
+          <a:xfrm>
+            <a:off x="3172968" y="5742432"/>
+            <a:ext cx="777240" cy="228600"/>
+          </a:xfrm>
+          <a:prstGeom prst="rect">
+            <a:avLst/>
+          </a:prstGeom>
+          <a:noFill/>
+        </p:spPr>
+        <p:txBody>
+          <a:bodyPr wrap="square">
+            <a:spAutoFit/>
+          </a:bodyPr>
+          <a:lstStyle/>
+          <a:p>
+            <a:pPr>
+              <a:defRPr sz="800" b="0">
+                <a:solidFill>
+                  <a:srgbClr val="6B7280"/>
+                </a:solidFill>
+                <a:latin typeface="Arial"/>
+              </a:defRPr>
+            </a:pPr>
+            <a:r>
+              <a:t>&lt;80</a:t>
+            </a:r>
+          </a:p>
+        </p:txBody>
+      </p:sp>
+      <p:sp>
+        <p:nvSpPr>
+          <p:cNvPr id="12" name="TextBox 11"/>
+          <p:cNvSpPr txBox="1"/>
+          <p:nvPr/>
+        </p:nvSpPr>
+        <p:spPr>
+          <a:xfrm>
+            <a:off x="411480" y="6446520"/>
+            <a:ext cx="11338560" cy="228600"/>
+          </a:xfrm>
+          <a:prstGeom prst="rect">
+            <a:avLst/>
+          </a:prstGeom>
+          <a:noFill/>
+        </p:spPr>
+        <p:txBody>
+          <a:bodyPr wrap="square">
+            <a:spAutoFit/>
+          </a:bodyPr>
+          <a:lstStyle/>
+          <a:p>
+            <a:pPr>
+              <a:defRPr sz="800" b="0">
+                <a:solidFill>
+                  <a:srgbClr val="6B7280"/>
+                </a:solidFill>
+                <a:latin typeface="Arial"/>
+              </a:defRPr>
+            </a:pPr>
+            <a:r>
+              <a:t>Index 2 example uses per-wafer median values for the same report indexes.</a:t>
+            </a:r>
+          </a:p>
+        </p:txBody>
+      </p:sp>
+    </p:spTree>
+  </p:cSld>
+  <p:clrMapOvr>
+    <a:masterClrMapping/>
+  </p:clrMapOvr>
+</p:sld>
+</file>
+
+<file path=ppt/slides/slide5.xml><?xml version="1.0" encoding="utf-8"?>
 <p:sld xmlns:a="http://schemas.openxmlformats.org/drawingml/2006/main" xmlns:p="http://schemas.openxmlformats.org/presentationml/2006/main" xmlns:r="http://schemas.openxmlformats.org/officeDocument/2006/relationships">
   <p:cSld>
     <p:spTree>

</xml_diff>